<commit_message>
updated final presentation ppt with NN Score
</commit_message>
<xml_diff>
--- a/assets/Final_Presentation.pptx
+++ b/assets/Final_Presentation.pptx
@@ -152,8 +152,8 @@
 <pc:chgInfo xmlns:a="http://schemas.openxmlformats.org/drawingml/2006/main" xmlns:r="http://schemas.openxmlformats.org/officeDocument/2006/relationships" xmlns:ac="http://schemas.microsoft.com/office/drawing/2013/main/command" xmlns:pc="http://schemas.microsoft.com/office/powerpoint/2013/main/command">
   <pc:docChgLst>
     <pc:chgData name="Rudraiah Gari, Rohith Reddy (Stud SRH-University)" userId="45fe41ad-b9ef-493d-bd71-3a924619f10c" providerId="ADAL" clId="{B0A560F6-E562-44DD-8F63-550E6F99639B}"/>
-    <pc:docChg chg="modSld">
-      <pc:chgData name="Rudraiah Gari, Rohith Reddy (Stud SRH-University)" userId="45fe41ad-b9ef-493d-bd71-3a924619f10c" providerId="ADAL" clId="{B0A560F6-E562-44DD-8F63-550E6F99639B}" dt="2026-07-21T22:48:41.153" v="14" actId="12100"/>
+    <pc:docChg chg="custSel modSld">
+      <pc:chgData name="Rudraiah Gari, Rohith Reddy (Stud SRH-University)" userId="45fe41ad-b9ef-493d-bd71-3a924619f10c" providerId="ADAL" clId="{B0A560F6-E562-44DD-8F63-550E6F99639B}" dt="2026-07-22T08:15:59.231" v="28" actId="20577"/>
       <pc:docMkLst>
         <pc:docMk/>
       </pc:docMkLst>
@@ -171,6 +171,21 @@
             <ac:picMk id="10" creationId="{35A29AD1-43FA-034E-CD08-76A6F39734F8}"/>
           </ac:picMkLst>
         </pc:picChg>
+      </pc:sldChg>
+      <pc:sldChg chg="modSp mod">
+        <pc:chgData name="Rudraiah Gari, Rohith Reddy (Stud SRH-University)" userId="45fe41ad-b9ef-493d-bd71-3a924619f10c" providerId="ADAL" clId="{B0A560F6-E562-44DD-8F63-550E6F99639B}" dt="2026-07-22T08:15:59.231" v="28" actId="20577"/>
+        <pc:sldMkLst>
+          <pc:docMk/>
+          <pc:sldMk cId="0" sldId="270"/>
+        </pc:sldMkLst>
+        <pc:graphicFrameChg chg="modGraphic">
+          <ac:chgData name="Rudraiah Gari, Rohith Reddy (Stud SRH-University)" userId="45fe41ad-b9ef-493d-bd71-3a924619f10c" providerId="ADAL" clId="{B0A560F6-E562-44DD-8F63-550E6F99639B}" dt="2026-07-22T08:15:59.231" v="28" actId="20577"/>
+          <ac:graphicFrameMkLst>
+            <pc:docMk/>
+            <pc:sldMk cId="0" sldId="270"/>
+            <ac:graphicFrameMk id="5" creationId="{3661C304-A6DD-FA6E-6BB4-0BA3B6810B3C}"/>
+          </ac:graphicFrameMkLst>
+        </pc:graphicFrameChg>
       </pc:sldChg>
       <pc:sldChg chg="modSp">
         <pc:chgData name="Rudraiah Gari, Rohith Reddy (Stud SRH-University)" userId="45fe41ad-b9ef-493d-bd71-3a924619f10c" providerId="ADAL" clId="{B0A560F6-E562-44DD-8F63-550E6F99639B}" dt="2026-07-21T22:40:07.513" v="3"/>
@@ -13383,7 +13398,7 @@
 <dgm:dataModel xmlns:dgm="http://schemas.openxmlformats.org/drawingml/2006/diagram" xmlns:a="http://schemas.openxmlformats.org/drawingml/2006/main">
   <dgm:ptLst>
     <dgm:pt modelId="{1AA12025-E7F2-4F71-84D0-9EB163DD9FAF}" type="doc">
-      <dgm:prSet loTypeId="urn:microsoft.com/office/officeart/2005/8/layout/vList2" loCatId="list" qsTypeId="urn:microsoft.com/office/officeart/2005/8/quickstyle/simple1" qsCatId="simple" csTypeId="urn:microsoft.com/office/officeart/2005/8/colors/colorful2" csCatId="colorful"/>
+      <dgm:prSet loTypeId="urn:microsoft.com/office/officeart/2005/8/layout/vList2" loCatId="list" qsTypeId="urn:microsoft.com/office/officeart/2005/8/quickstyle/simple1" qsCatId="simple" csTypeId="urn:microsoft.com/office/officeart/2005/8/colors/colorful2" csCatId="colorful" phldr="1"/>
       <dgm:spPr/>
       <dgm:t>
         <a:bodyPr/>
@@ -13617,8 +13632,16 @@
         <a:lstStyle/>
         <a:p>
           <a:r>
-            <a:rPr lang="en-IN"/>
-            <a:t>• Neural Network Baseline (MLPRegressor): Test MAE = ±33.5 runs | Test R² = 69.10%</a:t>
+            <a:rPr lang="en-IN" dirty="0"/>
+            <a:t>• Neural Network Baseline (</a:t>
+          </a:r>
+          <a:r>
+            <a:rPr lang="en-IN" dirty="0" err="1"/>
+            <a:t>MLPRegressor</a:t>
+          </a:r>
+          <a:r>
+            <a:rPr lang="en-IN" dirty="0"/>
+            <a:t>): Test MAE = ±35.3 runs | Test R² = 65.38%</a:t>
           </a:r>
         </a:p>
       </dgm:t>
@@ -15401,8 +15424,8 @@
         </a:p>
       </dgm:t>
     </dgm:pt>
-    <mc:AlternateContent xmlns:mc="http://schemas.openxmlformats.org/markup-compatibility/2006">
-      <mc:Choice xmlns:a14="http://schemas.microsoft.com/office/drawing/2010/main" Requires="a14">
+    <mc:AlternateContent xmlns:mc="http://schemas.openxmlformats.org/markup-compatibility/2006" xmlns:a14="http://schemas.microsoft.com/office/drawing/2010/main">
+      <mc:Choice Requires="a14">
         <dgm:pt modelId="{31597406-2864-473A-A680-909736EBBBF3}">
           <dgm:prSet/>
           <dgm:spPr/>
@@ -15419,7 +15442,7 @@
                   <m:sSup>
                     <m:sSupPr>
                       <m:ctrlPr>
-                        <a:rPr lang="en-IN">
+                        <a:rPr lang="en-IN" i="1">
                           <a:latin typeface="Cambria Math" panose="02040503050406030204" pitchFamily="18" charset="0"/>
                         </a:rPr>
                       </m:ctrlPr>
@@ -15451,7 +15474,7 @@
           </dgm:t>
         </dgm:pt>
       </mc:Choice>
-      <mc:Fallback>
+      <mc:Fallback xmlns="">
         <dgm:pt modelId="{31597406-2864-473A-A680-909736EBBBF3}">
           <dgm:prSet/>
           <dgm:spPr/>
@@ -20643,8 +20666,16 @@
             <a:buNone/>
           </a:pPr>
           <a:r>
-            <a:rPr lang="en-IN" sz="2000" kern="1200"/>
-            <a:t>• Neural Network Baseline (MLPRegressor): Test MAE = ±33.5 runs | Test R² = 69.10%</a:t>
+            <a:rPr lang="en-IN" sz="2000" kern="1200" dirty="0"/>
+            <a:t>• Neural Network Baseline (</a:t>
+          </a:r>
+          <a:r>
+            <a:rPr lang="en-IN" sz="2000" kern="1200" dirty="0" err="1"/>
+            <a:t>MLPRegressor</a:t>
+          </a:r>
+          <a:r>
+            <a:rPr lang="en-IN" sz="2000" kern="1200" dirty="0"/>
+            <a:t>): Test MAE = ±35.3 runs | Test R² = 65.38%</a:t>
           </a:r>
         </a:p>
       </dsp:txBody>
@@ -23339,7 +23370,7 @@
               <m:sSup>
                 <m:sSupPr>
                   <m:ctrlPr>
-                    <a:rPr lang="en-IN" sz="1500" kern="1200">
+                    <a:rPr lang="en-IN" sz="1500" i="1" kern="1200">
                       <a:latin typeface="Cambria Math" panose="02040503050406030204" pitchFamily="18" charset="0"/>
                     </a:rPr>
                   </m:ctrlPr>
@@ -49654,7 +49685,7 @@
           <a:p>
             <a:fld id="{5BCAD085-E8A6-8845-BD4E-CB4CCA059FC4}" type="datetimeFigureOut">
               <a:rPr lang="en-US" smtClean="0"/>
-              <a:t>7/21/2026</a:t>
+              <a:t>7/22/2026</a:t>
             </a:fld>
             <a:endParaRPr lang="en-US"/>
           </a:p>
@@ -49862,7 +49893,7 @@
           <a:p>
             <a:fld id="{5BCAD085-E8A6-8845-BD4E-CB4CCA059FC4}" type="datetimeFigureOut">
               <a:rPr lang="en-US" smtClean="0"/>
-              <a:t>7/21/2026</a:t>
+              <a:t>7/22/2026</a:t>
             </a:fld>
             <a:endParaRPr lang="en-US"/>
           </a:p>
@@ -50118,7 +50149,7 @@
           <a:p>
             <a:fld id="{5BCAD085-E8A6-8845-BD4E-CB4CCA059FC4}" type="datetimeFigureOut">
               <a:rPr lang="en-US" smtClean="0"/>
-              <a:t>7/21/2026</a:t>
+              <a:t>7/22/2026</a:t>
             </a:fld>
             <a:endParaRPr lang="en-US"/>
           </a:p>
@@ -50292,7 +50323,7 @@
           <a:p>
             <a:fld id="{5BCAD085-E8A6-8845-BD4E-CB4CCA059FC4}" type="datetimeFigureOut">
               <a:rPr lang="en-US" smtClean="0"/>
-              <a:t>7/21/2026</a:t>
+              <a:t>7/22/2026</a:t>
             </a:fld>
             <a:endParaRPr lang="en-US"/>
           </a:p>
@@ -50635,7 +50666,7 @@
           <a:p>
             <a:fld id="{5BCAD085-E8A6-8845-BD4E-CB4CCA059FC4}" type="datetimeFigureOut">
               <a:rPr lang="en-US" smtClean="0"/>
-              <a:t>7/21/2026</a:t>
+              <a:t>7/22/2026</a:t>
             </a:fld>
             <a:endParaRPr lang="en-US"/>
           </a:p>
@@ -50910,7 +50941,7 @@
           <a:p>
             <a:fld id="{5BCAD085-E8A6-8845-BD4E-CB4CCA059FC4}" type="datetimeFigureOut">
               <a:rPr lang="en-US" smtClean="0"/>
-              <a:t>7/21/2026</a:t>
+              <a:t>7/22/2026</a:t>
             </a:fld>
             <a:endParaRPr lang="en-US"/>
           </a:p>
@@ -51289,7 +51320,7 @@
           <a:p>
             <a:fld id="{5BCAD085-E8A6-8845-BD4E-CB4CCA059FC4}" type="datetimeFigureOut">
               <a:rPr lang="en-US" smtClean="0"/>
-              <a:t>7/21/2026</a:t>
+              <a:t>7/22/2026</a:t>
             </a:fld>
             <a:endParaRPr lang="en-US"/>
           </a:p>
@@ -51407,7 +51438,7 @@
           <a:p>
             <a:fld id="{5BCAD085-E8A6-8845-BD4E-CB4CCA059FC4}" type="datetimeFigureOut">
               <a:rPr lang="en-US" smtClean="0"/>
-              <a:t>7/21/2026</a:t>
+              <a:t>7/22/2026</a:t>
             </a:fld>
             <a:endParaRPr lang="en-US"/>
           </a:p>
@@ -51592,7 +51623,7 @@
           <a:p>
             <a:fld id="{5BCAD085-E8A6-8845-BD4E-CB4CCA059FC4}" type="datetimeFigureOut">
               <a:rPr lang="en-US" smtClean="0"/>
-              <a:t>7/21/2026</a:t>
+              <a:t>7/22/2026</a:t>
             </a:fld>
             <a:endParaRPr lang="en-US"/>
           </a:p>
@@ -51946,7 +51977,7 @@
           <a:p>
             <a:fld id="{5BCAD085-E8A6-8845-BD4E-CB4CCA059FC4}" type="datetimeFigureOut">
               <a:rPr lang="en-US" smtClean="0"/>
-              <a:t>7/21/2026</a:t>
+              <a:t>7/22/2026</a:t>
             </a:fld>
             <a:endParaRPr lang="en-US"/>
           </a:p>
@@ -52328,7 +52359,7 @@
           <a:p>
             <a:fld id="{5BCAD085-E8A6-8845-BD4E-CB4CCA059FC4}" type="datetimeFigureOut">
               <a:rPr lang="en-US" smtClean="0"/>
-              <a:t>7/21/2026</a:t>
+              <a:t>7/22/2026</a:t>
             </a:fld>
             <a:endParaRPr lang="en-US"/>
           </a:p>
@@ -52629,7 +52660,7 @@
           <a:p>
             <a:fld id="{5BCAD085-E8A6-8845-BD4E-CB4CCA059FC4}" type="datetimeFigureOut">
               <a:rPr lang="en-US" smtClean="0"/>
-              <a:t>7/21/2026</a:t>
+              <a:t>7/22/2026</a:t>
             </a:fld>
             <a:endParaRPr lang="en-US"/>
           </a:p>
@@ -54711,7 +54742,7 @@
           <p:nvPr>
             <p:extLst>
               <p:ext uri="{D42A27DB-BD31-4B8C-83A1-F6EECF244321}">
-                <p14:modId xmlns:p14="http://schemas.microsoft.com/office/powerpoint/2010/main" val="613928184"/>
+                <p14:modId xmlns:p14="http://schemas.microsoft.com/office/powerpoint/2010/main" val="1950063399"/>
               </p:ext>
             </p:extLst>
           </p:nvPr>
@@ -55885,8 +55916,8 @@
           </a:p>
         </p:txBody>
       </p:sp>
-      <mc:AlternateContent xmlns:mc="http://schemas.openxmlformats.org/markup-compatibility/2006">
-        <mc:Choice xmlns:a14="http://schemas.microsoft.com/office/drawing/2010/main" Requires="a14">
+      <mc:AlternateContent xmlns:mc="http://schemas.openxmlformats.org/markup-compatibility/2006" xmlns:a14="http://schemas.microsoft.com/office/drawing/2010/main">
+        <mc:Choice Requires="a14">
           <p:graphicFrame>
             <p:nvGraphicFramePr>
               <p:cNvPr id="5" name="Diagram 4">
@@ -55916,7 +55947,7 @@
             </a:graphic>
           </p:graphicFrame>
         </mc:Choice>
-        <mc:Fallback>
+        <mc:Fallback xmlns="">
           <p:graphicFrame>
             <p:nvGraphicFramePr>
               <p:cNvPr id="5" name="Diagram 4">
@@ -55941,7 +55972,7 @@
             </p:xfrm>
             <a:graphic>
               <a:graphicData uri="http://schemas.openxmlformats.org/drawingml/2006/diagram">
-                <dgm:relIds xmlns:dgm="http://schemas.openxmlformats.org/drawingml/2006/diagram" xmlns:r="http://schemas.openxmlformats.org/officeDocument/2006/relationships" r:dm="rId7" r:lo="rId3" r:qs="rId4" r:cs="rId5"/>
+                <dgm:relIds xmlns:dgm="http://schemas.openxmlformats.org/drawingml/2006/diagram" xmlns:r="http://schemas.openxmlformats.org/officeDocument/2006/relationships" r:dm="rId7" r:lo="rId8" r:qs="rId9" r:cs="rId10"/>
               </a:graphicData>
             </a:graphic>
           </p:graphicFrame>
@@ -58464,6 +58495,23 @@
 </file>
 
 <file path=customXml/item1.xml><?xml version="1.0" encoding="utf-8"?>
+<p:properties xmlns:p="http://schemas.microsoft.com/office/2006/metadata/properties" xmlns:xsi="http://www.w3.org/2001/XMLSchema-instance" xmlns:pc="http://schemas.microsoft.com/office/infopath/2007/PartnerControls">
+  <documentManagement>
+    <_activity xmlns="f1352c91-bc3e-45b1-b48e-5b8c53aa3f75" xsi:nil="true"/>
+  </documentManagement>
+</p:properties>
+</file>
+
+<file path=customXml/item2.xml><?xml version="1.0" encoding="utf-8"?>
+<?mso-contentType ?>
+<FormTemplates xmlns="http://schemas.microsoft.com/sharepoint/v3/contenttype/forms">
+  <Display>DocumentLibraryForm</Display>
+  <Edit>DocumentLibraryForm</Edit>
+  <New>DocumentLibraryForm</New>
+</FormTemplates>
+</file>
+
+<file path=customXml/item3.xml><?xml version="1.0" encoding="utf-8"?>
 <ct:contentTypeSchema xmlns:ct="http://schemas.microsoft.com/office/2006/metadata/contentType" xmlns:ma="http://schemas.microsoft.com/office/2006/metadata/properties/metaAttributes" ct:_="" ma:_="" ma:contentTypeName="Dokument" ma:contentTypeID="0x010100E02B0AF328649A4AB8E9FDF151CB4735" ma:contentTypeVersion="9" ma:contentTypeDescription="Ein neues Dokument erstellen." ma:contentTypeScope="" ma:versionID="d397de4fcaefc938acfd8f04fe572b8b">
   <xsd:schema xmlns:xsd="http://www.w3.org/2001/XMLSchema" xmlns:xs="http://www.w3.org/2001/XMLSchema" xmlns:p="http://schemas.microsoft.com/office/2006/metadata/properties" xmlns:ns3="f1352c91-bc3e-45b1-b48e-5b8c53aa3f75" targetNamespace="http://schemas.microsoft.com/office/2006/metadata/properties" ma:root="true" ma:fieldsID="fefa9b443f493af6d2b4645e7912fcdf" ns3:_="">
     <xsd:import namespace="f1352c91-bc3e-45b1-b48e-5b8c53aa3f75"/>
@@ -58637,24 +58685,31 @@
 </ct:contentTypeSchema>
 </file>
 
-<file path=customXml/item2.xml><?xml version="1.0" encoding="utf-8"?>
-<?mso-contentType ?>
-<FormTemplates xmlns="http://schemas.microsoft.com/sharepoint/v3/contenttype/forms">
-  <Display>DocumentLibraryForm</Display>
-  <Edit>DocumentLibraryForm</Edit>
-  <New>DocumentLibraryForm</New>
-</FormTemplates>
+<file path=customXml/itemProps1.xml><?xml version="1.0" encoding="utf-8"?>
+<ds:datastoreItem xmlns:ds="http://schemas.openxmlformats.org/officeDocument/2006/customXml" ds:itemID="{C6C3D09B-7B93-400A-B45A-100C3C0FBCF3}">
+  <ds:schemaRefs>
+    <ds:schemaRef ds:uri="http://schemas.openxmlformats.org/package/2006/metadata/core-properties"/>
+    <ds:schemaRef ds:uri="f1352c91-bc3e-45b1-b48e-5b8c53aa3f75"/>
+    <ds:schemaRef ds:uri="http://schemas.microsoft.com/office/2006/metadata/properties"/>
+    <ds:schemaRef ds:uri="http://www.w3.org/XML/1998/namespace"/>
+    <ds:schemaRef ds:uri="http://schemas.microsoft.com/office/2006/documentManagement/types"/>
+    <ds:schemaRef ds:uri="http://purl.org/dc/elements/1.1/"/>
+    <ds:schemaRef ds:uri="http://purl.org/dc/dcmitype/"/>
+    <ds:schemaRef ds:uri="http://schemas.microsoft.com/office/infopath/2007/PartnerControls"/>
+    <ds:schemaRef ds:uri="http://purl.org/dc/terms/"/>
+  </ds:schemaRefs>
+</ds:datastoreItem>
 </file>
 
-<file path=customXml/item3.xml><?xml version="1.0" encoding="utf-8"?>
-<p:properties xmlns:p="http://schemas.microsoft.com/office/2006/metadata/properties" xmlns:xsi="http://www.w3.org/2001/XMLSchema-instance" xmlns:pc="http://schemas.microsoft.com/office/infopath/2007/PartnerControls">
-  <documentManagement>
-    <_activity xmlns="f1352c91-bc3e-45b1-b48e-5b8c53aa3f75" xsi:nil="true"/>
-  </documentManagement>
-</p:properties>
+<file path=customXml/itemProps2.xml><?xml version="1.0" encoding="utf-8"?>
+<ds:datastoreItem xmlns:ds="http://schemas.openxmlformats.org/officeDocument/2006/customXml" ds:itemID="{E33C35BE-4233-4ECE-8F46-58DC00106D76}">
+  <ds:schemaRefs>
+    <ds:schemaRef ds:uri="http://schemas.microsoft.com/sharepoint/v3/contenttype/forms"/>
+  </ds:schemaRefs>
+</ds:datastoreItem>
 </file>
 
-<file path=customXml/itemProps1.xml><?xml version="1.0" encoding="utf-8"?>
+<file path=customXml/itemProps3.xml><?xml version="1.0" encoding="utf-8"?>
 <ds:datastoreItem xmlns:ds="http://schemas.openxmlformats.org/officeDocument/2006/customXml" ds:itemID="{88BD4B5C-8AF0-4479-9EB1-160423229AB4}">
   <ds:schemaRefs>
     <ds:schemaRef ds:uri="http://schemas.microsoft.com/office/2006/metadata/contentType"/>
@@ -58670,28 +58725,4 @@
     <ds:schemaRef ds:uri="http://schemas.microsoft.com/internal/obd"/>
   </ds:schemaRefs>
 </ds:datastoreItem>
-</file>
-
-<file path=customXml/itemProps2.xml><?xml version="1.0" encoding="utf-8"?>
-<ds:datastoreItem xmlns:ds="http://schemas.openxmlformats.org/officeDocument/2006/customXml" ds:itemID="{E33C35BE-4233-4ECE-8F46-58DC00106D76}">
-  <ds:schemaRefs>
-    <ds:schemaRef ds:uri="http://schemas.microsoft.com/sharepoint/v3/contenttype/forms"/>
-  </ds:schemaRefs>
-</ds:datastoreItem>
-</file>
-
-<file path=customXml/itemProps3.xml><?xml version="1.0" encoding="utf-8"?>
-<ds:datastoreItem xmlns:ds="http://schemas.openxmlformats.org/officeDocument/2006/customXml" ds:itemID="{C6C3D09B-7B93-400A-B45A-100C3C0FBCF3}">
-  <ds:schemaRefs>
-    <ds:schemaRef ds:uri="http://schemas.microsoft.com/office/2006/documentManagement/types"/>
-    <ds:schemaRef ds:uri="http://purl.org/dc/elements/1.1/"/>
-    <ds:schemaRef ds:uri="http://schemas.microsoft.com/office/2006/metadata/properties"/>
-    <ds:schemaRef ds:uri="f1352c91-bc3e-45b1-b48e-5b8c53aa3f75"/>
-    <ds:schemaRef ds:uri="http://schemas.openxmlformats.org/package/2006/metadata/core-properties"/>
-    <ds:schemaRef ds:uri="http://schemas.microsoft.com/office/infopath/2007/PartnerControls"/>
-    <ds:schemaRef ds:uri="http://www.w3.org/XML/1998/namespace"/>
-    <ds:schemaRef ds:uri="http://purl.org/dc/dcmitype/"/>
-    <ds:schemaRef ds:uri="http://purl.org/dc/terms/"/>
-  </ds:schemaRefs>
-</ds:datastoreItem>
 </file>
</xml_diff>

<commit_message>
updated final presentation ppt and model chart
</commit_message>
<xml_diff>
--- a/assets/Final_Presentation.pptx
+++ b/assets/Final_Presentation.pptx
@@ -55262,7 +55262,7 @@
         <p:spPr>
           <a:xfrm>
             <a:off x="685800" y="457200"/>
-            <a:ext cx="10789920" cy="914400"/>
+            <a:ext cx="6832768" cy="492443"/>
           </a:xfrm>
           <a:prstGeom prst="rect">
             <a:avLst/>
@@ -55284,7 +55284,7 @@
               </a:defRPr>
             </a:pPr>
             <a:r>
-              <a:t>Block 5: Honest Final Evaluation &amp; Error Analysis</a:t>
+              <a:t>Block 5: Final Evaluation &amp; Error Analysis</a:t>
             </a:r>
           </a:p>
         </p:txBody>
@@ -58495,20 +58495,20 @@
 </file>
 
 <file path=customXml/item1.xml><?xml version="1.0" encoding="utf-8"?>
-<p:properties xmlns:p="http://schemas.microsoft.com/office/2006/metadata/properties" xmlns:xsi="http://www.w3.org/2001/XMLSchema-instance" xmlns:pc="http://schemas.microsoft.com/office/infopath/2007/PartnerControls">
-  <documentManagement>
-    <_activity xmlns="f1352c91-bc3e-45b1-b48e-5b8c53aa3f75" xsi:nil="true"/>
-  </documentManagement>
-</p:properties>
-</file>
-
-<file path=customXml/item2.xml><?xml version="1.0" encoding="utf-8"?>
 <?mso-contentType ?>
 <FormTemplates xmlns="http://schemas.microsoft.com/sharepoint/v3/contenttype/forms">
   <Display>DocumentLibraryForm</Display>
   <Edit>DocumentLibraryForm</Edit>
   <New>DocumentLibraryForm</New>
 </FormTemplates>
+</file>
+
+<file path=customXml/item2.xml><?xml version="1.0" encoding="utf-8"?>
+<p:properties xmlns:p="http://schemas.microsoft.com/office/2006/metadata/properties" xmlns:xsi="http://www.w3.org/2001/XMLSchema-instance" xmlns:pc="http://schemas.microsoft.com/office/infopath/2007/PartnerControls">
+  <documentManagement>
+    <_activity xmlns="f1352c91-bc3e-45b1-b48e-5b8c53aa3f75" xsi:nil="true"/>
+  </documentManagement>
+</p:properties>
 </file>
 
 <file path=customXml/item3.xml><?xml version="1.0" encoding="utf-8"?>
@@ -58686,6 +58686,14 @@
 </file>
 
 <file path=customXml/itemProps1.xml><?xml version="1.0" encoding="utf-8"?>
+<ds:datastoreItem xmlns:ds="http://schemas.openxmlformats.org/officeDocument/2006/customXml" ds:itemID="{E33C35BE-4233-4ECE-8F46-58DC00106D76}">
+  <ds:schemaRefs>
+    <ds:schemaRef ds:uri="http://schemas.microsoft.com/sharepoint/v3/contenttype/forms"/>
+  </ds:schemaRefs>
+</ds:datastoreItem>
+</file>
+
+<file path=customXml/itemProps2.xml><?xml version="1.0" encoding="utf-8"?>
 <ds:datastoreItem xmlns:ds="http://schemas.openxmlformats.org/officeDocument/2006/customXml" ds:itemID="{C6C3D09B-7B93-400A-B45A-100C3C0FBCF3}">
   <ds:schemaRefs>
     <ds:schemaRef ds:uri="http://schemas.openxmlformats.org/package/2006/metadata/core-properties"/>
@@ -58697,14 +58705,6 @@
     <ds:schemaRef ds:uri="http://purl.org/dc/dcmitype/"/>
     <ds:schemaRef ds:uri="http://schemas.microsoft.com/office/infopath/2007/PartnerControls"/>
     <ds:schemaRef ds:uri="http://purl.org/dc/terms/"/>
-  </ds:schemaRefs>
-</ds:datastoreItem>
-</file>
-
-<file path=customXml/itemProps2.xml><?xml version="1.0" encoding="utf-8"?>
-<ds:datastoreItem xmlns:ds="http://schemas.openxmlformats.org/officeDocument/2006/customXml" ds:itemID="{E33C35BE-4233-4ECE-8F46-58DC00106D76}">
-  <ds:schemaRefs>
-    <ds:schemaRef ds:uri="http://schemas.microsoft.com/sharepoint/v3/contenttype/forms"/>
   </ds:schemaRefs>
 </ds:datastoreItem>
 </file>

</xml_diff>